<commit_message>
feat: added real prices
</commit_message>
<xml_diff>
--- a/docs/MedServicePrice_Presentation.pptx
+++ b/docs/MedServicePrice_Presentation.pptx
@@ -1756,7 +1756,7 @@
                 <a:ea typeface="Cambria" pitchFamily="34" charset="-122"/>
                 <a:cs typeface="Cambria" pitchFamily="34" charset="-120"/>
               </a:rPr>
-              <a:t>1602</a:t>
+              <a:t>3048</a:t>
             </a:r>
             <a:endParaRPr lang="en-US" sz="3400" dirty="0"/>
           </a:p>
@@ -1795,7 +1795,7 @@
                 <a:ea typeface="Calibri" pitchFamily="34" charset="-122"/>
                 <a:cs typeface="Calibri" pitchFamily="34" charset="-120"/>
               </a:rPr>
-              <a:t>цены</a:t>
+              <a:t>цен</a:t>
             </a:r>
             <a:endParaRPr lang="en-US" sz="1300" dirty="0"/>
           </a:p>
@@ -1834,7 +1834,7 @@
                 <a:ea typeface="Cambria" pitchFamily="34" charset="-122"/>
                 <a:cs typeface="Cambria" pitchFamily="34" charset="-120"/>
               </a:rPr>
-              <a:t>22</a:t>
+              <a:t>29</a:t>
             </a:r>
             <a:endParaRPr lang="en-US" sz="3400" dirty="0"/>
           </a:p>
@@ -1873,7 +1873,7 @@
                 <a:ea typeface="Calibri" pitchFamily="34" charset="-122"/>
                 <a:cs typeface="Calibri" pitchFamily="34" charset="-120"/>
               </a:rPr>
-              <a:t>клиники</a:t>
+              <a:t>клиник</a:t>
             </a:r>
             <a:endParaRPr lang="en-US" sz="1300" dirty="0"/>
           </a:p>
@@ -1912,7 +1912,7 @@
                 <a:ea typeface="Cambria" pitchFamily="34" charset="-122"/>
                 <a:cs typeface="Cambria" pitchFamily="34" charset="-120"/>
               </a:rPr>
-              <a:t>10</a:t>
+              <a:t>17</a:t>
             </a:r>
             <a:endParaRPr lang="en-US" sz="3400" dirty="0"/>
           </a:p>
@@ -2887,7 +2887,7 @@
                 <a:ea typeface="Calibri" pitchFamily="34" charset="-122"/>
                 <a:cs typeface="Calibri" pitchFamily="34" charset="-120"/>
               </a:rPr>
-              <a:t>XLSX · DOCX</a:t>
+              <a:t>XLSX/XLS · DOCX</a:t>
             </a:r>
             <a:endParaRPr lang="en-US" sz="1200" dirty="0"/>
           </a:p>
@@ -6118,7 +6118,7 @@
                 <a:ea typeface="Cambria" pitchFamily="34" charset="-122"/>
                 <a:cs typeface="Cambria" pitchFamily="34" charset="-120"/>
               </a:rPr>
-              <a:t>1602</a:t>
+              <a:t>3048</a:t>
             </a:r>
             <a:endParaRPr lang="en-US" sz="3000" dirty="0"/>
           </a:p>
@@ -6218,7 +6218,7 @@
                 <a:ea typeface="Cambria" pitchFamily="34" charset="-122"/>
                 <a:cs typeface="Cambria" pitchFamily="34" charset="-120"/>
               </a:rPr>
-              <a:t>22</a:t>
+              <a:t>29</a:t>
             </a:r>
             <a:endParaRPr lang="en-US" sz="3000" dirty="0"/>
           </a:p>
@@ -6257,7 +6257,7 @@
                 <a:ea typeface="Calibri" pitchFamily="34" charset="-122"/>
                 <a:cs typeface="Calibri" pitchFamily="34" charset="-120"/>
               </a:rPr>
-              <a:t>клиники</a:t>
+              <a:t>клиник</a:t>
             </a:r>
             <a:endParaRPr lang="en-US" sz="1300" dirty="0"/>
           </a:p>
@@ -6518,7 +6518,7 @@
                 <a:ea typeface="Cambria" pitchFamily="34" charset="-122"/>
                 <a:cs typeface="Cambria" pitchFamily="34" charset="-120"/>
               </a:rPr>
-              <a:t>10</a:t>
+              <a:t>17</a:t>
             </a:r>
             <a:endParaRPr lang="en-US" sz="3000" dirty="0"/>
           </a:p>
@@ -6618,7 +6618,7 @@
                 <a:ea typeface="Cambria" pitchFamily="34" charset="-122"/>
                 <a:cs typeface="Cambria" pitchFamily="34" charset="-120"/>
               </a:rPr>
-              <a:t>99%</a:t>
+              <a:t>7</a:t>
             </a:r>
             <a:endParaRPr lang="en-US" sz="3000" dirty="0"/>
           </a:p>
@@ -6657,7 +6657,7 @@
                 <a:ea typeface="Calibri" pitchFamily="34" charset="-122"/>
                 <a:cs typeface="Calibri" pitchFamily="34" charset="-120"/>
               </a:rPr>
-              <a:t>нормализовано</a:t>
+              <a:t>реальных прайсов</a:t>
             </a:r>
             <a:endParaRPr lang="en-US" sz="1300" dirty="0"/>
           </a:p>

</xml_diff>